<commit_message>
Add official frontier and safe scheduler analysis
</commit_message>
<xml_diff>
--- a/slides/final_presentation.pptx
+++ b/slides/final_presentation.pptx
@@ -16,6 +16,7 @@
     <p:sldId id="264" r:id="rId15"/>
     <p:sldId id="265" r:id="rId16"/>
     <p:sldId id="266" r:id="rId17"/>
+    <p:sldId id="267" r:id="rId18"/>
   </p:sldIdLst>
   <p:sldSz cx="12191695" cy="6858000" type="screen4x3"/>
   <p:notesSz cx="6858000" cy="9144000"/>
@@ -3288,7 +3289,7 @@
               </a:defRPr>
             </a:pPr>
             <a:r>
-              <a:t>Limitations</a:t>
+              <a:t>Phase-Wise Analysis</a:t>
             </a:r>
           </a:p>
         </p:txBody>
@@ -3302,7 +3303,7 @@
         <p:spPr>
           <a:xfrm>
             <a:off x="594360" y="1234440"/>
-            <a:ext cx="10789920" cy="4389120"/>
+            <a:ext cx="5257800" cy="4389120"/>
           </a:xfrm>
           <a:prstGeom prst="rect">
             <a:avLst/>
@@ -3322,7 +3323,7 @@
               <a:defRPr sz="1800"/>
             </a:pPr>
             <a:r>
-              <a:t>Improvement numbers are from the surrogate, not official benchmark rollouts</a:t>
+              <a:t>Free-space approach tolerates longer chunks</a:t>
             </a:r>
           </a:p>
           <a:p>
@@ -3333,7 +3334,7 @@
               <a:defRPr sz="1800"/>
             </a:pPr>
             <a:r>
-              <a:t>Official run uses compatibility patches and scores below checkpoint filename</a:t>
+              <a:t>Contact pushing needs frequent replanning</a:t>
             </a:r>
           </a:p>
           <a:p>
@@ -3344,33 +3345,35 @@
               <a:defRPr sz="1800"/>
             </a:pPr>
             <a:r>
-              <a:t>LeRobot checkpoint path is executable but not SHA-verified</a:t>
-            </a:r>
-          </a:p>
-          <a:p>
-            <a:pPr>
-              <a:spcAft>
-                <a:spcPts val="800"/>
-              </a:spcAft>
-              <a:defRPr sz="1800"/>
-            </a:pPr>
-            <a:r>
-              <a:t>B=k/h is an approximate compute model</a:t>
-            </a:r>
-          </a:p>
-          <a:p>
-            <a:pPr>
-              <a:spcAft>
-                <a:spcPts val="800"/>
-              </a:spcAft>
-              <a:defRPr sz="1800"/>
-            </a:pPr>
-            <a:r>
-              <a:t>No real-robot validation</a:t>
-            </a:r>
-          </a:p>
-        </p:txBody>
-      </p:sp>
+              <a:t>Near-goal alignment benefits from smoother denoised chunks</a:t>
+            </a:r>
+          </a:p>
+        </p:txBody>
+      </p:sp>
+      <p:pic>
+        <p:nvPicPr>
+          <p:cNvPr id="4" name="Picture 3" descr="phase_wise_scores.png"/>
+          <p:cNvPicPr>
+            <a:picLocks noChangeAspect="1"/>
+          </p:cNvPicPr>
+          <p:nvPr/>
+        </p:nvPicPr>
+        <p:blipFill>
+          <a:blip r:embed="rId2"/>
+          <a:stretch>
+            <a:fillRect/>
+          </a:stretch>
+        </p:blipFill>
+        <p:spPr>
+          <a:xfrm>
+            <a:off x="6035040" y="1234440"/>
+            <a:ext cx="5577840" cy="3346704"/>
+          </a:xfrm>
+          <a:prstGeom prst="rect">
+            <a:avLst/>
+          </a:prstGeom>
+        </p:spPr>
+      </p:pic>
     </p:spTree>
   </p:cSld>
   <p:clrMapOvr>
@@ -3427,7 +3430,7 @@
               </a:defRPr>
             </a:pPr>
             <a:r>
-              <a:t>Takeaways</a:t>
+              <a:t>Limitations</a:t>
             </a:r>
           </a:p>
         </p:txBody>
@@ -3461,7 +3464,7 @@
               <a:defRPr sz="1800"/>
             </a:pPr>
             <a:r>
-              <a:t>Denoising and replanning are coupled deployment decisions</a:t>
+              <a:t>Improvement numbers are from the surrogate, not official benchmark rollouts</a:t>
             </a:r>
           </a:p>
           <a:p>
@@ -3472,7 +3475,7 @@
               <a:defRPr sz="1800"/>
             </a:pPr>
             <a:r>
-              <a:t>Best allocation changes by task phase</a:t>
+              <a:t>Official run uses compatibility patches and scores below checkpoint filename</a:t>
             </a:r>
           </a:p>
           <a:p>
@@ -3483,7 +3486,157 @@
               <a:defRPr sz="1800"/>
             </a:pPr>
             <a:r>
-              <a:t>A simple joint scheduler can improve the score-smoothness tradeoff under the same budget</a:t>
+              <a:t>Official fixed-(k,h) frontier favors high denoising</a:t>
+            </a:r>
+          </a:p>
+          <a:p>
+            <a:pPr>
+              <a:spcAft>
+                <a:spcPts val="800"/>
+              </a:spcAft>
+              <a:defRPr sz="1800"/>
+            </a:pPr>
+            <a:r>
+              <a:t>LeRobot checkpoint path is executable but not SHA-verified</a:t>
+            </a:r>
+          </a:p>
+          <a:p>
+            <a:pPr>
+              <a:spcAft>
+                <a:spcPts val="800"/>
+              </a:spcAft>
+              <a:defRPr sz="1800"/>
+            </a:pPr>
+            <a:r>
+              <a:t>B=k/h is an approximate compute model</a:t>
+            </a:r>
+          </a:p>
+          <a:p>
+            <a:pPr>
+              <a:spcAft>
+                <a:spcPts val="800"/>
+              </a:spcAft>
+              <a:defRPr sz="1800"/>
+            </a:pPr>
+            <a:r>
+              <a:t>No real-robot validation</a:t>
+            </a:r>
+          </a:p>
+        </p:txBody>
+      </p:sp>
+    </p:spTree>
+  </p:cSld>
+  <p:clrMapOvr>
+    <a:masterClrMapping/>
+  </p:clrMapOvr>
+</p:sld>
+</file>
+
+<file path=ppt/slides/slide12.xml><?xml version="1.0" encoding="utf-8"?>
+<p:sld xmlns:a="http://schemas.openxmlformats.org/drawingml/2006/main" xmlns:p="http://schemas.openxmlformats.org/presentationml/2006/main" xmlns:r="http://schemas.openxmlformats.org/officeDocument/2006/relationships">
+  <p:cSld>
+    <p:bg>
+      <p:bgPr>
+        <a:solidFill>
+          <a:srgbClr val="FAFAF9"/>
+        </a:solidFill>
+        <a:effectLst/>
+      </p:bgPr>
+    </p:bg>
+    <p:spTree>
+      <p:nvGrpSpPr>
+        <p:cNvPr id="1" name=""/>
+        <p:cNvGrpSpPr/>
+        <p:nvPr/>
+      </p:nvGrpSpPr>
+      <p:grpSpPr/>
+      <p:sp>
+        <p:nvSpPr>
+          <p:cNvPr id="2" name="TextBox 1"/>
+          <p:cNvSpPr txBox="1"/>
+          <p:nvPr/>
+        </p:nvSpPr>
+        <p:spPr>
+          <a:xfrm>
+            <a:off x="411480" y="228600"/>
+            <a:ext cx="11338560" cy="640080"/>
+          </a:xfrm>
+          <a:prstGeom prst="rect">
+            <a:avLst/>
+          </a:prstGeom>
+          <a:noFill/>
+        </p:spPr>
+        <p:txBody>
+          <a:bodyPr wrap="none">
+            <a:spAutoFit/>
+          </a:bodyPr>
+          <a:lstStyle/>
+          <a:p>
+            <a:pPr>
+              <a:defRPr sz="3000" b="1">
+                <a:solidFill>
+                  <a:srgbClr val="1F2937"/>
+                </a:solidFill>
+              </a:defRPr>
+            </a:pPr>
+            <a:r>
+              <a:t>Takeaways</a:t>
+            </a:r>
+          </a:p>
+        </p:txBody>
+      </p:sp>
+      <p:sp>
+        <p:nvSpPr>
+          <p:cNvPr id="3" name="TextBox 2"/>
+          <p:cNvSpPr txBox="1"/>
+          <p:nvPr/>
+        </p:nvSpPr>
+        <p:spPr>
+          <a:xfrm>
+            <a:off x="594360" y="1234440"/>
+            <a:ext cx="10789920" cy="4389120"/>
+          </a:xfrm>
+          <a:prstGeom prst="rect">
+            <a:avLst/>
+          </a:prstGeom>
+          <a:noFill/>
+        </p:spPr>
+        <p:txBody>
+          <a:bodyPr wrap="none">
+            <a:spAutoFit/>
+          </a:bodyPr>
+          <a:lstStyle/>
+          <a:p>
+            <a:pPr>
+              <a:spcAft>
+                <a:spcPts val="800"/>
+              </a:spcAft>
+              <a:defRPr sz="1800"/>
+            </a:pPr>
+            <a:r>
+              <a:t>Denoising and replanning are coupled deployment decisions</a:t>
+            </a:r>
+          </a:p>
+          <a:p>
+            <a:pPr>
+              <a:spcAft>
+                <a:spcPts val="800"/>
+              </a:spcAft>
+              <a:defRPr sz="1800"/>
+            </a:pPr>
+            <a:r>
+              <a:t>Best allocation changes by task phase and checkpoint</a:t>
+            </a:r>
+          </a:p>
+          <a:p>
+            <a:pPr>
+              <a:spcAft>
+                <a:spcPts val="800"/>
+              </a:spcAft>
+              <a:defRPr sz="1800"/>
+            </a:pPr>
+            <a:r>
+              <a:t>A simple joint scheduler can improve the score-smoothness or success-cost tradeoff under the same budget</a:t>
             </a:r>
           </a:p>
         </p:txBody>
@@ -3965,7 +4118,7 @@
               </a:defRPr>
             </a:pPr>
             <a:r>
-              <a:t>LeRobot PushT Checkpoint</a:t>
+              <a:t>Official Frontier</a:t>
             </a:r>
           </a:p>
         </p:txBody>
@@ -3979,7 +4132,7 @@
         <p:spPr>
           <a:xfrm>
             <a:off x="594360" y="1234440"/>
-            <a:ext cx="10789920" cy="4389120"/>
+            <a:ext cx="5257800" cy="4389120"/>
           </a:xfrm>
           <a:prstGeom prst="rect">
             <a:avLst/>
@@ -3999,7 +4152,7 @@
               <a:defRPr sz="1800"/>
             </a:pPr>
             <a:r>
-              <a:t>Model card 500-episode max reward: 0.955</a:t>
+              <a:t>20-seed official fixed-(k,h) sweep</a:t>
             </a:r>
           </a:p>
           <a:p>
@@ -4010,7 +4163,7 @@
               <a:defRPr sz="1800"/>
             </a:pPr>
             <a:r>
-              <a:t>Model card success rate: 65.4%</a:t>
+              <a:t>Best tested official point: (100,8)</a:t>
             </a:r>
           </a:p>
           <a:p>
@@ -4021,7 +4174,7 @@
               <a:defRPr sz="1800"/>
             </a:pPr>
             <a:r>
-              <a:t>Local safetensors loads and runs in real gym-pusht</a:t>
+              <a:t>Score: 0.949, success: 0.950</a:t>
             </a:r>
           </a:p>
           <a:p>
@@ -4032,22 +4185,35 @@
               <a:defRPr sz="1800"/>
             </a:pPr>
             <a:r>
-              <a:t>Local smoke: max reward 0.627, 100 denoising steps</a:t>
-            </a:r>
-          </a:p>
-          <a:p>
-            <a:pPr>
-              <a:spcAft>
-                <a:spcPts val="800"/>
-              </a:spcAft>
-              <a:defRPr sz="1800"/>
-            </a:pPr>
-            <a:r>
-              <a:t>Caveat: mirror file did not pass HF LFS SHA check</a:t>
-            </a:r>
-          </a:p>
-        </p:txBody>
-      </p:sp>
+              <a:t>Low-k frequent replanning does not rescue this checkpoint</a:t>
+            </a:r>
+          </a:p>
+        </p:txBody>
+      </p:sp>
+      <p:pic>
+        <p:nvPicPr>
+          <p:cNvPr id="4" name="Picture 3" descr="official_kh_frontier.png"/>
+          <p:cNvPicPr>
+            <a:picLocks noChangeAspect="1"/>
+          </p:cNvPicPr>
+          <p:nvPr/>
+        </p:nvPicPr>
+        <p:blipFill>
+          <a:blip r:embed="rId2"/>
+          <a:stretch>
+            <a:fillRect/>
+          </a:stretch>
+        </p:blipFill>
+        <p:spPr>
+          <a:xfrm>
+            <a:off x="6035040" y="1234440"/>
+            <a:ext cx="5577840" cy="3127674"/>
+          </a:xfrm>
+          <a:prstGeom prst="rect">
+            <a:avLst/>
+          </a:prstGeom>
+        </p:spPr>
+      </p:pic>
     </p:spTree>
   </p:cSld>
   <p:clrMapOvr>
@@ -4104,7 +4270,7 @@
               </a:defRPr>
             </a:pPr>
             <a:r>
-              <a:t>Static Grid</a:t>
+              <a:t>LeRobot PushT Checkpoint</a:t>
             </a:r>
           </a:p>
         </p:txBody>
@@ -4118,7 +4284,7 @@
         <p:spPr>
           <a:xfrm>
             <a:off x="594360" y="1234440"/>
-            <a:ext cx="5257800" cy="4389120"/>
+            <a:ext cx="10789920" cy="4389120"/>
           </a:xfrm>
           <a:prstGeom prst="rect">
             <a:avLst/>
@@ -4138,7 +4304,7 @@
               <a:defRPr sz="1800"/>
             </a:pPr>
             <a:r>
-              <a:t>Grid: k in {2,4,8,16}, h in {1,2,4,8}</a:t>
+              <a:t>Model card 500-episode max reward: 0.955</a:t>
             </a:r>
           </a:p>
           <a:p>
@@ -4149,7 +4315,7 @@
               <a:defRPr sz="1800"/>
             </a:pPr>
             <a:r>
-              <a:t>Contact-rich pushing makes equal-compute points behave differently</a:t>
+              <a:t>Model card success rate: 65.4%</a:t>
             </a:r>
           </a:p>
           <a:p>
@@ -4160,35 +4326,33 @@
               <a:defRPr sz="1800"/>
             </a:pPr>
             <a:r>
-              <a:t>The best fixed B=2 score point is (2,1)</a:t>
-            </a:r>
-          </a:p>
-        </p:txBody>
-      </p:sp>
-      <p:pic>
-        <p:nvPicPr>
-          <p:cNvPr id="4" name="Picture 3" descr="kh_score_heatmap.png"/>
-          <p:cNvPicPr>
-            <a:picLocks noChangeAspect="1"/>
-          </p:cNvPicPr>
-          <p:nvPr/>
-        </p:nvPicPr>
-        <p:blipFill>
-          <a:blip r:embed="rId2"/>
-          <a:stretch>
-            <a:fillRect/>
-          </a:stretch>
-        </p:blipFill>
-        <p:spPr>
-          <a:xfrm>
-            <a:off x="6035040" y="1234440"/>
-            <a:ext cx="5577840" cy="4028440"/>
-          </a:xfrm>
-          <a:prstGeom prst="rect">
-            <a:avLst/>
-          </a:prstGeom>
-        </p:spPr>
-      </p:pic>
+              <a:t>Local safetensors loads and runs in real gym-pusht</a:t>
+            </a:r>
+          </a:p>
+          <a:p>
+            <a:pPr>
+              <a:spcAft>
+                <a:spcPts val="800"/>
+              </a:spcAft>
+              <a:defRPr sz="1800"/>
+            </a:pPr>
+            <a:r>
+              <a:t>Local smoke: max reward 0.627, 100 denoising steps</a:t>
+            </a:r>
+          </a:p>
+          <a:p>
+            <a:pPr>
+              <a:spcAft>
+                <a:spcPts val="800"/>
+              </a:spcAft>
+              <a:defRPr sz="1800"/>
+            </a:pPr>
+            <a:r>
+              <a:t>Caveat: mirror file did not pass HF LFS SHA check</a:t>
+            </a:r>
+          </a:p>
+        </p:txBody>
+      </p:sp>
     </p:spTree>
   </p:cSld>
   <p:clrMapOvr>
@@ -4245,7 +4409,7 @@
               </a:defRPr>
             </a:pPr>
             <a:r>
-              <a:t>Joint Scheduler</a:t>
+              <a:t>Static Grid</a:t>
             </a:r>
           </a:p>
         </p:txBody>
@@ -4259,7 +4423,7 @@
         <p:spPr>
           <a:xfrm>
             <a:off x="594360" y="1234440"/>
-            <a:ext cx="10789920" cy="4389120"/>
+            <a:ext cx="5257800" cy="4389120"/>
           </a:xfrm>
           <a:prstGeom prst="rect">
             <a:avLst/>
@@ -4279,7 +4443,7 @@
               <a:defRPr sz="1800"/>
             </a:pPr>
             <a:r>
-              <a:t>Training-free rule on the B=2 frontier</a:t>
+              <a:t>Grid: k in {2,4,8,16}, h in {1,2,4,8}</a:t>
             </a:r>
           </a:p>
           <a:p>
@@ -4290,7 +4454,7 @@
               <a:defRPr sz="1800"/>
             </a:pPr>
             <a:r>
-              <a:t>Use (4,2) for free-space approach and final alignment</a:t>
+              <a:t>Contact-rich pushing makes equal-compute points behave differently</a:t>
             </a:r>
           </a:p>
           <a:p>
@@ -4301,22 +4465,35 @@
               <a:defRPr sz="1800"/>
             </a:pPr>
             <a:r>
-              <a:t>Use (2,1) during close-contact pushing or unstable progress</a:t>
-            </a:r>
-          </a:p>
-          <a:p>
-            <a:pPr>
-              <a:spcAft>
-                <a:spcPts val="800"/>
-              </a:spcAft>
-              <a:defRPr sz="1800"/>
-            </a:pPr>
-            <a:r>
-              <a:t>Goal: keep compute fixed while moving reactivity to high-risk phases</a:t>
-            </a:r>
-          </a:p>
-        </p:txBody>
-      </p:sp>
+              <a:t>The best fixed B=2 score point is (2,1)</a:t>
+            </a:r>
+          </a:p>
+        </p:txBody>
+      </p:sp>
+      <p:pic>
+        <p:nvPicPr>
+          <p:cNvPr id="4" name="Picture 3" descr="kh_score_heatmap.png"/>
+          <p:cNvPicPr>
+            <a:picLocks noChangeAspect="1"/>
+          </p:cNvPicPr>
+          <p:nvPr/>
+        </p:nvPicPr>
+        <p:blipFill>
+          <a:blip r:embed="rId2"/>
+          <a:stretch>
+            <a:fillRect/>
+          </a:stretch>
+        </p:blipFill>
+        <p:spPr>
+          <a:xfrm>
+            <a:off x="6035040" y="1234440"/>
+            <a:ext cx="5577840" cy="4028440"/>
+          </a:xfrm>
+          <a:prstGeom prst="rect">
+            <a:avLst/>
+          </a:prstGeom>
+        </p:spPr>
+      </p:pic>
     </p:spTree>
   </p:cSld>
   <p:clrMapOvr>
@@ -4373,7 +4550,7 @@
               </a:defRPr>
             </a:pPr>
             <a:r>
-              <a:t>Main Results</a:t>
+              <a:t>Joint Scheduler</a:t>
             </a:r>
           </a:p>
         </p:txBody>
@@ -4387,7 +4564,7 @@
         <p:spPr>
           <a:xfrm>
             <a:off x="594360" y="1234440"/>
-            <a:ext cx="5257800" cy="4389120"/>
+            <a:ext cx="10789920" cy="4389120"/>
           </a:xfrm>
           <a:prstGeom prst="rect">
             <a:avLst/>
@@ -4407,7 +4584,7 @@
               <a:defRPr sz="1800"/>
             </a:pPr>
             <a:r>
-              <a:t>Joint score: 0.937</a:t>
+              <a:t>Training-free rule on the B=2 frontier</a:t>
             </a:r>
           </a:p>
           <a:p>
@@ -4418,7 +4595,7 @@
               <a:defRPr sz="1800"/>
             </a:pPr>
             <a:r>
-              <a:t>Best fixed B=2 score: 0.925</a:t>
+              <a:t>Score variant uses (4,2) in easier phases and (2,1) near contact</a:t>
             </a:r>
           </a:p>
           <a:p>
@@ -4429,7 +4606,7 @@
               <a:defRPr sz="1800"/>
             </a:pPr>
             <a:r>
-              <a:t>Policy calls: 90.8 vs 120.0</a:t>
+              <a:t>Safe variant switches to (2,1) earlier</a:t>
             </a:r>
           </a:p>
           <a:p>
@@ -4440,35 +4617,11 @@
               <a:defRPr sz="1800"/>
             </a:pPr>
             <a:r>
-              <a:t>Smoothness cost: 0.271 vs 0.444</a:t>
-            </a:r>
-          </a:p>
-        </p:txBody>
-      </p:sp>
-      <p:pic>
-        <p:nvPicPr>
-          <p:cNvPr id="4" name="Picture 3" descr="main_comparison_bars.png"/>
-          <p:cNvPicPr>
-            <a:picLocks noChangeAspect="1"/>
-          </p:cNvPicPr>
-          <p:nvPr/>
-        </p:nvPicPr>
-        <p:blipFill>
-          <a:blip r:embed="rId2"/>
-          <a:stretch>
-            <a:fillRect/>
-          </a:stretch>
-        </p:blipFill>
-        <p:spPr>
-          <a:xfrm>
-            <a:off x="6035040" y="1234440"/>
-            <a:ext cx="5577840" cy="2252589"/>
-          </a:xfrm>
-          <a:prstGeom prst="rect">
-            <a:avLst/>
-          </a:prstGeom>
-        </p:spPr>
-      </p:pic>
+              <a:t>Goal: keep compute fixed while moving reactivity to high-risk phases</a:t>
+            </a:r>
+          </a:p>
+        </p:txBody>
+      </p:sp>
     </p:spTree>
   </p:cSld>
   <p:clrMapOvr>
@@ -4525,7 +4678,7 @@
               </a:defRPr>
             </a:pPr>
             <a:r>
-              <a:t>Phase-Wise Analysis</a:t>
+              <a:t>Main Results</a:t>
             </a:r>
           </a:p>
         </p:txBody>
@@ -4559,7 +4712,7 @@
               <a:defRPr sz="1800"/>
             </a:pPr>
             <a:r>
-              <a:t>Free-space approach tolerates longer chunks</a:t>
+              <a:t>Score scheduler: score 0.893, calls 89.2</a:t>
             </a:r>
           </a:p>
           <a:p>
@@ -4570,7 +4723,7 @@
               <a:defRPr sz="1800"/>
             </a:pPr>
             <a:r>
-              <a:t>Contact pushing needs frequent replanning</a:t>
+              <a:t>Safe scheduler: success 0.950, calls 105.3</a:t>
             </a:r>
           </a:p>
           <a:p>
@@ -4581,14 +4734,25 @@
               <a:defRPr sz="1800"/>
             </a:pPr>
             <a:r>
-              <a:t>Near-goal alignment benefits from smoother denoised chunks</a:t>
+              <a:t>Best fixed B=2: score 0.871, success 0.900</a:t>
+            </a:r>
+          </a:p>
+          <a:p>
+            <a:pPr>
+              <a:spcAft>
+                <a:spcPts val="800"/>
+              </a:spcAft>
+              <a:defRPr sz="1800"/>
+            </a:pPr>
+            <a:r>
+              <a:t>Result is a Pareto tradeoff, not a single universal winner</a:t>
             </a:r>
           </a:p>
         </p:txBody>
       </p:sp>
       <p:pic>
         <p:nvPicPr>
-          <p:cNvPr id="4" name="Picture 3" descr="phase_wise_scores.png"/>
+          <p:cNvPr id="4" name="Picture 3" descr="main_comparison_bars.png"/>
           <p:cNvPicPr>
             <a:picLocks noChangeAspect="1"/>
           </p:cNvPicPr>
@@ -4603,7 +4767,7 @@
         <p:spPr>
           <a:xfrm>
             <a:off x="6035040" y="1234440"/>
-            <a:ext cx="5577840" cy="3346704"/>
+            <a:ext cx="5577840" cy="2252589"/>
           </a:xfrm>
           <a:prstGeom prst="rect">
             <a:avLst/>

</xml_diff>

<commit_message>
Add official DDIM sampler improvement
</commit_message>
<xml_diff>
--- a/slides/final_presentation.pptx
+++ b/slides/final_presentation.pptx
@@ -13,10 +13,6 @@
     <p:sldId id="261" r:id="rId12"/>
     <p:sldId id="262" r:id="rId13"/>
     <p:sldId id="263" r:id="rId14"/>
-    <p:sldId id="264" r:id="rId15"/>
-    <p:sldId id="265" r:id="rId16"/>
-    <p:sldId id="266" r:id="rId17"/>
-    <p:sldId id="267" r:id="rId18"/>
   </p:sldIdLst>
   <p:sldSz cx="12191695" cy="6858000" type="screen4x3"/>
   <p:notesSz cx="6858000" cy="9144000"/>
@@ -3116,7 +3112,7 @@
         <p:spPr>
           <a:xfrm>
             <a:off x="411480" y="228600"/>
-            <a:ext cx="11338560" cy="640080"/>
+            <a:ext cx="11155680" cy="594360"/>
           </a:xfrm>
           <a:prstGeom prst="rect">
             <a:avLst/>
@@ -3137,7 +3133,7 @@
               </a:defRPr>
             </a:pPr>
             <a:r>
-              <a:t>Joint Compute-Control Budgeting</a:t>
+              <a:t>Project Position</a:t>
             </a:r>
           </a:p>
         </p:txBody>
@@ -3150,8 +3146,8 @@
         </p:nvSpPr>
         <p:spPr>
           <a:xfrm>
-            <a:off x="438912" y="804672"/>
-            <a:ext cx="10972800" cy="320040"/>
+            <a:off x="594360" y="1143000"/>
+            <a:ext cx="10789920" cy="5120640"/>
           </a:xfrm>
           <a:prstGeom prst="rect">
             <a:avLst/>
@@ -3165,39 +3161,15 @@
           <a:lstStyle/>
           <a:p>
             <a:pPr>
-              <a:defRPr sz="1300">
-                <a:solidFill>
-                  <a:srgbClr val="4B5563"/>
-                </a:solidFill>
-              </a:defRPr>
+              <a:spcAft>
+                <a:spcPts val="800"/>
+              </a:spcAft>
+              <a:defRPr sz="1800"/>
             </a:pPr>
             <a:r>
-              <a:t>Iso-compute denoising and replanning for Diffusion Policy-style control</a:t>
-            </a:r>
-          </a:p>
-        </p:txBody>
-      </p:sp>
-      <p:sp>
-        <p:nvSpPr>
-          <p:cNvPr id="4" name="TextBox 3"/>
-          <p:cNvSpPr txBox="1"/>
-          <p:nvPr/>
-        </p:nvSpPr>
-        <p:spPr>
-          <a:xfrm>
-            <a:off x="594360" y="1234440"/>
-            <a:ext cx="10789920" cy="4389120"/>
-          </a:xfrm>
-          <a:prstGeom prst="rect">
-            <a:avLst/>
-          </a:prstGeom>
-          <a:noFill/>
-        </p:spPr>
-        <p:txBody>
-          <a:bodyPr wrap="none">
-            <a:spAutoFit/>
-          </a:bodyPr>
-          <a:lstStyle/>
+              <a:t>Reproduce official Diffusion Policy Push-T</a:t>
+            </a:r>
+          </a:p>
           <a:p>
             <a:pPr>
               <a:spcAft>
@@ -3206,7 +3178,7 @@
               <a:defRPr sz="1800"/>
             </a:pPr>
             <a:r>
-              <a:t>Final project: reproduce a robotics paper and add an improvement idea</a:t>
+              <a:t>Implement inference-time DDIM sampler replacement</a:t>
             </a:r>
           </a:p>
           <a:p>
@@ -3217,7 +3189,7 @@
               <a:defRPr sz="1800"/>
             </a:pPr>
             <a:r>
-              <a:t>Base paper: Diffusion Policy, RSS 2023</a:t>
+              <a:t>Evaluate on official checkpoint rollouts</a:t>
             </a:r>
           </a:p>
           <a:p>
@@ -3228,415 +3200,7 @@
               <a:defRPr sz="1800"/>
             </a:pPr>
             <a:r>
-              <a:t>Task: Push-T-style closed-loop contact benchmark</a:t>
-            </a:r>
-          </a:p>
-        </p:txBody>
-      </p:sp>
-    </p:spTree>
-  </p:cSld>
-  <p:clrMapOvr>
-    <a:masterClrMapping/>
-  </p:clrMapOvr>
-</p:sld>
-</file>
-
-<file path=ppt/slides/slide10.xml><?xml version="1.0" encoding="utf-8"?>
-<p:sld xmlns:a="http://schemas.openxmlformats.org/drawingml/2006/main" xmlns:p="http://schemas.openxmlformats.org/presentationml/2006/main" xmlns:r="http://schemas.openxmlformats.org/officeDocument/2006/relationships">
-  <p:cSld>
-    <p:bg>
-      <p:bgPr>
-        <a:solidFill>
-          <a:srgbClr val="FAFAF9"/>
-        </a:solidFill>
-        <a:effectLst/>
-      </p:bgPr>
-    </p:bg>
-    <p:spTree>
-      <p:nvGrpSpPr>
-        <p:cNvPr id="1" name=""/>
-        <p:cNvGrpSpPr/>
-        <p:nvPr/>
-      </p:nvGrpSpPr>
-      <p:grpSpPr/>
-      <p:sp>
-        <p:nvSpPr>
-          <p:cNvPr id="2" name="TextBox 1"/>
-          <p:cNvSpPr txBox="1"/>
-          <p:nvPr/>
-        </p:nvSpPr>
-        <p:spPr>
-          <a:xfrm>
-            <a:off x="411480" y="228600"/>
-            <a:ext cx="11338560" cy="640080"/>
-          </a:xfrm>
-          <a:prstGeom prst="rect">
-            <a:avLst/>
-          </a:prstGeom>
-          <a:noFill/>
-        </p:spPr>
-        <p:txBody>
-          <a:bodyPr wrap="none">
-            <a:spAutoFit/>
-          </a:bodyPr>
-          <a:lstStyle/>
-          <a:p>
-            <a:pPr>
-              <a:defRPr sz="3000" b="1">
-                <a:solidFill>
-                  <a:srgbClr val="1F2937"/>
-                </a:solidFill>
-              </a:defRPr>
-            </a:pPr>
-            <a:r>
-              <a:t>Phase-Wise Analysis</a:t>
-            </a:r>
-          </a:p>
-        </p:txBody>
-      </p:sp>
-      <p:sp>
-        <p:nvSpPr>
-          <p:cNvPr id="3" name="TextBox 2"/>
-          <p:cNvSpPr txBox="1"/>
-          <p:nvPr/>
-        </p:nvSpPr>
-        <p:spPr>
-          <a:xfrm>
-            <a:off x="594360" y="1234440"/>
-            <a:ext cx="5257800" cy="4389120"/>
-          </a:xfrm>
-          <a:prstGeom prst="rect">
-            <a:avLst/>
-          </a:prstGeom>
-          <a:noFill/>
-        </p:spPr>
-        <p:txBody>
-          <a:bodyPr wrap="none">
-            <a:spAutoFit/>
-          </a:bodyPr>
-          <a:lstStyle/>
-          <a:p>
-            <a:pPr>
-              <a:spcAft>
-                <a:spcPts val="800"/>
-              </a:spcAft>
-              <a:defRPr sz="1800"/>
-            </a:pPr>
-            <a:r>
-              <a:t>Free-space approach tolerates longer chunks</a:t>
-            </a:r>
-          </a:p>
-          <a:p>
-            <a:pPr>
-              <a:spcAft>
-                <a:spcPts val="800"/>
-              </a:spcAft>
-              <a:defRPr sz="1800"/>
-            </a:pPr>
-            <a:r>
-              <a:t>Contact pushing needs frequent replanning</a:t>
-            </a:r>
-          </a:p>
-          <a:p>
-            <a:pPr>
-              <a:spcAft>
-                <a:spcPts val="800"/>
-              </a:spcAft>
-              <a:defRPr sz="1800"/>
-            </a:pPr>
-            <a:r>
-              <a:t>Near-goal alignment benefits from smoother denoised chunks</a:t>
-            </a:r>
-          </a:p>
-        </p:txBody>
-      </p:sp>
-      <p:pic>
-        <p:nvPicPr>
-          <p:cNvPr id="4" name="Picture 3" descr="phase_wise_scores.png"/>
-          <p:cNvPicPr>
-            <a:picLocks noChangeAspect="1"/>
-          </p:cNvPicPr>
-          <p:nvPr/>
-        </p:nvPicPr>
-        <p:blipFill>
-          <a:blip r:embed="rId2"/>
-          <a:stretch>
-            <a:fillRect/>
-          </a:stretch>
-        </p:blipFill>
-        <p:spPr>
-          <a:xfrm>
-            <a:off x="6035040" y="1234440"/>
-            <a:ext cx="5577840" cy="3346704"/>
-          </a:xfrm>
-          <a:prstGeom prst="rect">
-            <a:avLst/>
-          </a:prstGeom>
-        </p:spPr>
-      </p:pic>
-    </p:spTree>
-  </p:cSld>
-  <p:clrMapOvr>
-    <a:masterClrMapping/>
-  </p:clrMapOvr>
-</p:sld>
-</file>
-
-<file path=ppt/slides/slide11.xml><?xml version="1.0" encoding="utf-8"?>
-<p:sld xmlns:a="http://schemas.openxmlformats.org/drawingml/2006/main" xmlns:p="http://schemas.openxmlformats.org/presentationml/2006/main" xmlns:r="http://schemas.openxmlformats.org/officeDocument/2006/relationships">
-  <p:cSld>
-    <p:bg>
-      <p:bgPr>
-        <a:solidFill>
-          <a:srgbClr val="FAFAF9"/>
-        </a:solidFill>
-        <a:effectLst/>
-      </p:bgPr>
-    </p:bg>
-    <p:spTree>
-      <p:nvGrpSpPr>
-        <p:cNvPr id="1" name=""/>
-        <p:cNvGrpSpPr/>
-        <p:nvPr/>
-      </p:nvGrpSpPr>
-      <p:grpSpPr/>
-      <p:sp>
-        <p:nvSpPr>
-          <p:cNvPr id="2" name="TextBox 1"/>
-          <p:cNvSpPr txBox="1"/>
-          <p:nvPr/>
-        </p:nvSpPr>
-        <p:spPr>
-          <a:xfrm>
-            <a:off x="411480" y="228600"/>
-            <a:ext cx="11338560" cy="640080"/>
-          </a:xfrm>
-          <a:prstGeom prst="rect">
-            <a:avLst/>
-          </a:prstGeom>
-          <a:noFill/>
-        </p:spPr>
-        <p:txBody>
-          <a:bodyPr wrap="none">
-            <a:spAutoFit/>
-          </a:bodyPr>
-          <a:lstStyle/>
-          <a:p>
-            <a:pPr>
-              <a:defRPr sz="3000" b="1">
-                <a:solidFill>
-                  <a:srgbClr val="1F2937"/>
-                </a:solidFill>
-              </a:defRPr>
-            </a:pPr>
-            <a:r>
-              <a:t>Limitations</a:t>
-            </a:r>
-          </a:p>
-        </p:txBody>
-      </p:sp>
-      <p:sp>
-        <p:nvSpPr>
-          <p:cNvPr id="3" name="TextBox 2"/>
-          <p:cNvSpPr txBox="1"/>
-          <p:nvPr/>
-        </p:nvSpPr>
-        <p:spPr>
-          <a:xfrm>
-            <a:off x="594360" y="1234440"/>
-            <a:ext cx="10789920" cy="4389120"/>
-          </a:xfrm>
-          <a:prstGeom prst="rect">
-            <a:avLst/>
-          </a:prstGeom>
-          <a:noFill/>
-        </p:spPr>
-        <p:txBody>
-          <a:bodyPr wrap="none">
-            <a:spAutoFit/>
-          </a:bodyPr>
-          <a:lstStyle/>
-          <a:p>
-            <a:pPr>
-              <a:spcAft>
-                <a:spcPts val="800"/>
-              </a:spcAft>
-              <a:defRPr sz="1800"/>
-            </a:pPr>
-            <a:r>
-              <a:t>Improvement numbers are from the surrogate, not official benchmark rollouts</a:t>
-            </a:r>
-          </a:p>
-          <a:p>
-            <a:pPr>
-              <a:spcAft>
-                <a:spcPts val="800"/>
-              </a:spcAft>
-              <a:defRPr sz="1800"/>
-            </a:pPr>
-            <a:r>
-              <a:t>Official run uses compatibility patches and scores below checkpoint filename</a:t>
-            </a:r>
-          </a:p>
-          <a:p>
-            <a:pPr>
-              <a:spcAft>
-                <a:spcPts val="800"/>
-              </a:spcAft>
-              <a:defRPr sz="1800"/>
-            </a:pPr>
-            <a:r>
-              <a:t>Official fixed-(k,h) frontier favors high denoising</a:t>
-            </a:r>
-          </a:p>
-          <a:p>
-            <a:pPr>
-              <a:spcAft>
-                <a:spcPts val="800"/>
-              </a:spcAft>
-              <a:defRPr sz="1800"/>
-            </a:pPr>
-            <a:r>
-              <a:t>LeRobot checkpoint path is executable but not SHA-verified</a:t>
-            </a:r>
-          </a:p>
-          <a:p>
-            <a:pPr>
-              <a:spcAft>
-                <a:spcPts val="800"/>
-              </a:spcAft>
-              <a:defRPr sz="1800"/>
-            </a:pPr>
-            <a:r>
-              <a:t>B=k/h is an approximate compute model</a:t>
-            </a:r>
-          </a:p>
-          <a:p>
-            <a:pPr>
-              <a:spcAft>
-                <a:spcPts val="800"/>
-              </a:spcAft>
-              <a:defRPr sz="1800"/>
-            </a:pPr>
-            <a:r>
-              <a:t>No real-robot validation</a:t>
-            </a:r>
-          </a:p>
-        </p:txBody>
-      </p:sp>
-    </p:spTree>
-  </p:cSld>
-  <p:clrMapOvr>
-    <a:masterClrMapping/>
-  </p:clrMapOvr>
-</p:sld>
-</file>
-
-<file path=ppt/slides/slide12.xml><?xml version="1.0" encoding="utf-8"?>
-<p:sld xmlns:a="http://schemas.openxmlformats.org/drawingml/2006/main" xmlns:p="http://schemas.openxmlformats.org/presentationml/2006/main" xmlns:r="http://schemas.openxmlformats.org/officeDocument/2006/relationships">
-  <p:cSld>
-    <p:bg>
-      <p:bgPr>
-        <a:solidFill>
-          <a:srgbClr val="FAFAF9"/>
-        </a:solidFill>
-        <a:effectLst/>
-      </p:bgPr>
-    </p:bg>
-    <p:spTree>
-      <p:nvGrpSpPr>
-        <p:cNvPr id="1" name=""/>
-        <p:cNvGrpSpPr/>
-        <p:nvPr/>
-      </p:nvGrpSpPr>
-      <p:grpSpPr/>
-      <p:sp>
-        <p:nvSpPr>
-          <p:cNvPr id="2" name="TextBox 1"/>
-          <p:cNvSpPr txBox="1"/>
-          <p:nvPr/>
-        </p:nvSpPr>
-        <p:spPr>
-          <a:xfrm>
-            <a:off x="411480" y="228600"/>
-            <a:ext cx="11338560" cy="640080"/>
-          </a:xfrm>
-          <a:prstGeom prst="rect">
-            <a:avLst/>
-          </a:prstGeom>
-          <a:noFill/>
-        </p:spPr>
-        <p:txBody>
-          <a:bodyPr wrap="none">
-            <a:spAutoFit/>
-          </a:bodyPr>
-          <a:lstStyle/>
-          <a:p>
-            <a:pPr>
-              <a:defRPr sz="3000" b="1">
-                <a:solidFill>
-                  <a:srgbClr val="1F2937"/>
-                </a:solidFill>
-              </a:defRPr>
-            </a:pPr>
-            <a:r>
-              <a:t>Takeaways</a:t>
-            </a:r>
-          </a:p>
-        </p:txBody>
-      </p:sp>
-      <p:sp>
-        <p:nvSpPr>
-          <p:cNvPr id="3" name="TextBox 2"/>
-          <p:cNvSpPr txBox="1"/>
-          <p:nvPr/>
-        </p:nvSpPr>
-        <p:spPr>
-          <a:xfrm>
-            <a:off x="594360" y="1234440"/>
-            <a:ext cx="10789920" cy="4389120"/>
-          </a:xfrm>
-          <a:prstGeom prst="rect">
-            <a:avLst/>
-          </a:prstGeom>
-          <a:noFill/>
-        </p:spPr>
-        <p:txBody>
-          <a:bodyPr wrap="none">
-            <a:spAutoFit/>
-          </a:bodyPr>
-          <a:lstStyle/>
-          <a:p>
-            <a:pPr>
-              <a:spcAft>
-                <a:spcPts val="800"/>
-              </a:spcAft>
-              <a:defRPr sz="1800"/>
-            </a:pPr>
-            <a:r>
-              <a:t>Denoising and replanning are coupled deployment decisions</a:t>
-            </a:r>
-          </a:p>
-          <a:p>
-            <a:pPr>
-              <a:spcAft>
-                <a:spcPts val="800"/>
-              </a:spcAft>
-              <a:defRPr sz="1800"/>
-            </a:pPr>
-            <a:r>
-              <a:t>Best allocation changes by task phase and checkpoint</a:t>
-            </a:r>
-          </a:p>
-          <a:p>
-            <a:pPr>
-              <a:spcAft>
-                <a:spcPts val="800"/>
-              </a:spcAft>
-              <a:defRPr sz="1800"/>
-            </a:pPr>
-            <a:r>
-              <a:t>A simple joint scheduler can improve the score-smoothness or success-cost tradeoff under the same budget</a:t>
+              <a:t>Keep claim bounded and matched-seed</a:t>
             </a:r>
           </a:p>
         </p:txBody>
@@ -3676,7 +3240,7 @@
         <p:spPr>
           <a:xfrm>
             <a:off x="411480" y="228600"/>
-            <a:ext cx="11338560" cy="640080"/>
+            <a:ext cx="11155680" cy="594360"/>
           </a:xfrm>
           <a:prstGeom prst="rect">
             <a:avLst/>
@@ -3697,7 +3261,7 @@
               </a:defRPr>
             </a:pPr>
             <a:r>
-              <a:t>Motivation</a:t>
+              <a:t>Official Reproduction</a:t>
             </a:r>
           </a:p>
         </p:txBody>
@@ -3710,8 +3274,8 @@
         </p:nvSpPr>
         <p:spPr>
           <a:xfrm>
-            <a:off x="594360" y="1234440"/>
-            <a:ext cx="5257800" cy="4389120"/>
+            <a:off x="594360" y="1143000"/>
+            <a:ext cx="10789920" cy="5120640"/>
           </a:xfrm>
           <a:prstGeom prst="rect">
             <a:avLst/>
@@ -3731,7 +3295,7 @@
               <a:defRPr sz="1800"/>
             </a:pPr>
             <a:r>
-              <a:t>Diffusion Policy is accurate but iterative denoising is expensive</a:t>
+              <a:t>Official source and checkpoint loaded</a:t>
             </a:r>
           </a:p>
           <a:p>
@@ -3742,7 +3306,7 @@
               <a:defRPr sz="1800"/>
             </a:pPr>
             <a:r>
-              <a:t>Replanning improves reactivity but increases policy calls</a:t>
+              <a:t>50-seed DDPM reproduction score: 0.9187</a:t>
             </a:r>
           </a:p>
           <a:p>
@@ -3753,35 +3317,22 @@
               <a:defRPr sz="1800"/>
             </a:pPr>
             <a:r>
-              <a:t>Deployment needs a fixed per-step inference budget</a:t>
-            </a:r>
-          </a:p>
-        </p:txBody>
-      </p:sp>
-      <p:pic>
-        <p:nvPicPr>
-          <p:cNvPr id="4" name="Picture 3" descr="pareto_score_compute.png"/>
-          <p:cNvPicPr>
-            <a:picLocks noChangeAspect="1"/>
-          </p:cNvPicPr>
-          <p:nvPr/>
-        </p:nvPicPr>
-        <p:blipFill>
-          <a:blip r:embed="rId2"/>
-          <a:stretch>
-            <a:fillRect/>
-          </a:stretch>
-        </p:blipFill>
-        <p:spPr>
-          <a:xfrm>
-            <a:off x="6035040" y="1234440"/>
-            <a:ext cx="5577840" cy="3768811"/>
-          </a:xfrm>
-          <a:prstGeom prst="rect">
-            <a:avLst/>
-          </a:prstGeom>
-        </p:spPr>
-      </p:pic>
+              <a:t>Compatibility environment gap documented</a:t>
+            </a:r>
+          </a:p>
+          <a:p>
+            <a:pPr>
+              <a:spcAft>
+                <a:spcPts val="800"/>
+              </a:spcAft>
+              <a:defRPr sz="1800"/>
+            </a:pPr>
+            <a:r>
+              <a:t>Baseline runner preserved</a:t>
+            </a:r>
+          </a:p>
+        </p:txBody>
+      </p:sp>
     </p:spTree>
   </p:cSld>
   <p:clrMapOvr>
@@ -3817,7 +3368,7 @@
         <p:spPr>
           <a:xfrm>
             <a:off x="411480" y="228600"/>
-            <a:ext cx="11338560" cy="640080"/>
+            <a:ext cx="11155680" cy="594360"/>
           </a:xfrm>
           <a:prstGeom prst="rect">
             <a:avLst/>
@@ -3838,7 +3389,7 @@
               </a:defRPr>
             </a:pPr>
             <a:r>
-              <a:t>Key Question</a:t>
+              <a:t>Improvement Idea</a:t>
             </a:r>
           </a:p>
         </p:txBody>
@@ -3851,8 +3402,8 @@
         </p:nvSpPr>
         <p:spPr>
           <a:xfrm>
-            <a:off x="594360" y="1234440"/>
-            <a:ext cx="5257800" cy="4389120"/>
+            <a:off x="594360" y="1143000"/>
+            <a:ext cx="10789920" cy="5120640"/>
           </a:xfrm>
           <a:prstGeom prst="rect">
             <a:avLst/>
@@ -3872,7 +3423,7 @@
               <a:defRPr sz="1800"/>
             </a:pPr>
             <a:r>
-              <a:t>Should compute be spent on larger k or smaller h?</a:t>
+              <a:t>Replace DDPM ancestral sampler with DDIM deterministic sampler</a:t>
             </a:r>
           </a:p>
           <a:p>
@@ -3883,7 +3434,7 @@
               <a:defRPr sz="1800"/>
             </a:pPr>
             <a:r>
-              <a:t>k: denoising steps per policy call</a:t>
+              <a:t>No retraining and no model weight changes</a:t>
             </a:r>
           </a:p>
           <a:p>
@@ -3894,7 +3445,7 @@
               <a:defRPr sz="1800"/>
             </a:pPr>
             <a:r>
-              <a:t>h: executed controls before replanning</a:t>
+              <a:t>Same Push-T env, same seeds, same (k,h)</a:t>
             </a:r>
           </a:p>
           <a:p>
@@ -3905,35 +3456,11 @@
               <a:defRPr sz="1800"/>
             </a:pPr>
             <a:r>
-              <a:t>B ~= k / h is the iso-compute budget</a:t>
-            </a:r>
-          </a:p>
-        </p:txBody>
-      </p:sp>
-      <p:pic>
-        <p:nvPicPr>
-          <p:cNvPr id="4" name="Picture 3" descr="iso_compute_curves.png"/>
-          <p:cNvPicPr>
-            <a:picLocks noChangeAspect="1"/>
-          </p:cNvPicPr>
-          <p:nvPr/>
-        </p:nvPicPr>
-        <p:blipFill>
-          <a:blip r:embed="rId2"/>
-          <a:stretch>
-            <a:fillRect/>
-          </a:stretch>
-        </p:blipFill>
-        <p:spPr>
-          <a:xfrm>
-            <a:off x="6035040" y="1234440"/>
-            <a:ext cx="5577840" cy="3768811"/>
-          </a:xfrm>
-          <a:prstGeom prst="rect">
-            <a:avLst/>
-          </a:prstGeom>
-        </p:spPr>
-      </p:pic>
+              <a:t>Implemented in run_official_kh_grid.py --sampler ddim</a:t>
+            </a:r>
+          </a:p>
+        </p:txBody>
+      </p:sp>
     </p:spTree>
   </p:cSld>
   <p:clrMapOvr>
@@ -3969,7 +3496,7 @@
         <p:spPr>
           <a:xfrm>
             <a:off x="411480" y="228600"/>
-            <a:ext cx="11338560" cy="640080"/>
+            <a:ext cx="11155680" cy="594360"/>
           </a:xfrm>
           <a:prstGeom prst="rect">
             <a:avLst/>
@@ -3990,7 +3517,7 @@
               </a:defRPr>
             </a:pPr>
             <a:r>
-              <a:t>Reproduction Setup</a:t>
+              <a:t>Main Results</a:t>
             </a:r>
           </a:p>
         </p:txBody>
@@ -4003,8 +3530,8 @@
         </p:nvSpPr>
         <p:spPr>
           <a:xfrm>
-            <a:off x="594360" y="1234440"/>
-            <a:ext cx="10789920" cy="4389120"/>
+            <a:off x="594360" y="1143000"/>
+            <a:ext cx="5394960" cy="5120640"/>
           </a:xfrm>
           <a:prstGeom prst="rect">
             <a:avLst/>
@@ -4024,7 +3551,7 @@
               <a:defRPr sz="1800"/>
             </a:pPr>
             <a:r>
-              <a:t>Official source acquired via GitHub codeload archive</a:t>
+              <a:t>(25,2): 0.155 -&gt; 0.900, success 0.000 -&gt; 0.800</a:t>
             </a:r>
           </a:p>
           <a:p>
@@ -4035,7 +3562,7 @@
               <a:defRPr sz="1800"/>
             </a:pPr>
             <a:r>
-              <a:t>Official Push-T checkpoint downloaded: 1044185793 bytes</a:t>
+              <a:t>(50,4): 0.653 -&gt; 0.929, success 0.350 -&gt; 0.750</a:t>
             </a:r>
           </a:p>
           <a:p>
@@ -4046,7 +3573,7 @@
               <a:defRPr sz="1800"/>
             </a:pPr>
             <a:r>
-              <a:t>50-seed official runner score: 0.919</a:t>
+              <a:t>(100,8): 0.949 -&gt; 0.900, DDPM remains strongest</a:t>
             </a:r>
           </a:p>
           <a:p>
@@ -4057,11 +3584,35 @@
               <a:defRPr sz="1800"/>
             </a:pPr>
             <a:r>
-              <a:t>Compatibility patches needed for Python 3.12 / Gym 0.26</a:t>
-            </a:r>
-          </a:p>
-        </p:txBody>
-      </p:sp>
+              <a:t>DDIM improves low/mid-denoising frontier</a:t>
+            </a:r>
+          </a:p>
+        </p:txBody>
+      </p:sp>
+      <p:pic>
+        <p:nvPicPr>
+          <p:cNvPr id="4" name="Picture 3" descr="official_sampler_comparison.png"/>
+          <p:cNvPicPr>
+            <a:picLocks noChangeAspect="1"/>
+          </p:cNvPicPr>
+          <p:nvPr/>
+        </p:nvPicPr>
+        <p:blipFill>
+          <a:blip r:embed="rId2"/>
+          <a:stretch>
+            <a:fillRect/>
+          </a:stretch>
+        </p:blipFill>
+        <p:spPr>
+          <a:xfrm>
+            <a:off x="6126480" y="1143000"/>
+            <a:ext cx="5486400" cy="2215662"/>
+          </a:xfrm>
+          <a:prstGeom prst="rect">
+            <a:avLst/>
+          </a:prstGeom>
+        </p:spPr>
+      </p:pic>
     </p:spTree>
   </p:cSld>
   <p:clrMapOvr>
@@ -4097,7 +3648,7 @@
         <p:spPr>
           <a:xfrm>
             <a:off x="411480" y="228600"/>
-            <a:ext cx="11338560" cy="640080"/>
+            <a:ext cx="11155680" cy="594360"/>
           </a:xfrm>
           <a:prstGeom prst="rect">
             <a:avLst/>
@@ -4118,7 +3669,7 @@
               </a:defRPr>
             </a:pPr>
             <a:r>
-              <a:t>Official Frontier</a:t>
+              <a:t>Statistical Check</a:t>
             </a:r>
           </a:p>
         </p:txBody>
@@ -4131,8 +3682,8 @@
         </p:nvSpPr>
         <p:spPr>
           <a:xfrm>
-            <a:off x="594360" y="1234440"/>
-            <a:ext cx="5257800" cy="4389120"/>
+            <a:off x="594360" y="1143000"/>
+            <a:ext cx="10789920" cy="5120640"/>
           </a:xfrm>
           <a:prstGeom prst="rect">
             <a:avLst/>
@@ -4152,7 +3703,7 @@
               <a:defRPr sz="1800"/>
             </a:pPr>
             <a:r>
-              <a:t>20-seed official fixed-(k,h) sweep</a:t>
+              <a:t>20 matched official Push-T seeds</a:t>
             </a:r>
           </a:p>
           <a:p>
@@ -4163,7 +3714,7 @@
               <a:defRPr sz="1800"/>
             </a:pPr>
             <a:r>
-              <a:t>Best tested official point: (100,8)</a:t>
+              <a:t>Paired bootstrap CI positive for (25,2) and (50,4)</a:t>
             </a:r>
           </a:p>
           <a:p>
@@ -4174,7 +3725,7 @@
               <a:defRPr sz="1800"/>
             </a:pPr>
             <a:r>
-              <a:t>Score: 0.949, success: 0.950</a:t>
+              <a:t>(100,8) CI includes zero and mean favors DDPM</a:t>
             </a:r>
           </a:p>
           <a:p>
@@ -4185,35 +3736,11 @@
               <a:defRPr sz="1800"/>
             </a:pPr>
             <a:r>
-              <a:t>Low-k frequent replanning does not rescue this checkpoint</a:t>
-            </a:r>
-          </a:p>
-        </p:txBody>
-      </p:sp>
-      <p:pic>
-        <p:nvPicPr>
-          <p:cNvPr id="4" name="Picture 3" descr="official_kh_frontier.png"/>
-          <p:cNvPicPr>
-            <a:picLocks noChangeAspect="1"/>
-          </p:cNvPicPr>
-          <p:nvPr/>
-        </p:nvPicPr>
-        <p:blipFill>
-          <a:blip r:embed="rId2"/>
-          <a:stretch>
-            <a:fillRect/>
-          </a:stretch>
-        </p:blipFill>
-        <p:spPr>
-          <a:xfrm>
-            <a:off x="6035040" y="1234440"/>
-            <a:ext cx="5577840" cy="3127674"/>
-          </a:xfrm>
-          <a:prstGeom prst="rect">
-            <a:avLst/>
-          </a:prstGeom>
-        </p:spPr>
-      </p:pic>
+              <a:t>No universal dominance claim</a:t>
+            </a:r>
+          </a:p>
+        </p:txBody>
+      </p:sp>
     </p:spTree>
   </p:cSld>
   <p:clrMapOvr>
@@ -4249,7 +3776,7 @@
         <p:spPr>
           <a:xfrm>
             <a:off x="411480" y="228600"/>
-            <a:ext cx="11338560" cy="640080"/>
+            <a:ext cx="11155680" cy="594360"/>
           </a:xfrm>
           <a:prstGeom prst="rect">
             <a:avLst/>
@@ -4270,7 +3797,7 @@
               </a:defRPr>
             </a:pPr>
             <a:r>
-              <a:t>LeRobot PushT Checkpoint</a:t>
+              <a:t>Claim Boundary</a:t>
             </a:r>
           </a:p>
         </p:txBody>
@@ -4283,8 +3810,8 @@
         </p:nvSpPr>
         <p:spPr>
           <a:xfrm>
-            <a:off x="594360" y="1234440"/>
-            <a:ext cx="10789920" cy="4389120"/>
+            <a:off x="594360" y="1143000"/>
+            <a:ext cx="10789920" cy="5120640"/>
           </a:xfrm>
           <a:prstGeom prst="rect">
             <a:avLst/>
@@ -4304,7 +3831,7 @@
               <a:defRPr sz="1800"/>
             </a:pPr>
             <a:r>
-              <a:t>Model card 500-episode max reward: 0.955</a:t>
+              <a:t>This is not a new sampler algorithm</a:t>
             </a:r>
           </a:p>
           <a:p>
@@ -4315,7 +3842,7 @@
               <a:defRPr sz="1800"/>
             </a:pPr>
             <a:r>
-              <a:t>Model card success rate: 65.4%</a:t>
+              <a:t>DDIM is known prior work</a:t>
             </a:r>
           </a:p>
           <a:p>
@@ -4326,7 +3853,7 @@
               <a:defRPr sz="1800"/>
             </a:pPr>
             <a:r>
-              <a:t>Local safetensors loads and runs in real gym-pusht</a:t>
+              <a:t>Contribution: application and validation on official checkpoint</a:t>
             </a:r>
           </a:p>
           <a:p>
@@ -4337,18 +3864,7 @@
               <a:defRPr sz="1800"/>
             </a:pPr>
             <a:r>
-              <a:t>Local smoke: max reward 0.627, 100 denoising steps</a:t>
-            </a:r>
-          </a:p>
-          <a:p>
-            <a:pPr>
-              <a:spcAft>
-                <a:spcPts val="800"/>
-              </a:spcAft>
-              <a:defRPr sz="1800"/>
-            </a:pPr>
-            <a:r>
-              <a:t>Caveat: mirror file did not pass HF LFS SHA check</a:t>
+              <a:t>Surrogate scheduler is not headline evidence</a:t>
             </a:r>
           </a:p>
         </p:txBody>
@@ -4388,7 +3904,7 @@
         <p:spPr>
           <a:xfrm>
             <a:off x="411480" y="228600"/>
-            <a:ext cx="11338560" cy="640080"/>
+            <a:ext cx="11155680" cy="594360"/>
           </a:xfrm>
           <a:prstGeom prst="rect">
             <a:avLst/>
@@ -4409,7 +3925,7 @@
               </a:defRPr>
             </a:pPr>
             <a:r>
-              <a:t>Static Grid</a:t>
+              <a:t>Limitations</a:t>
             </a:r>
           </a:p>
         </p:txBody>
@@ -4422,8 +3938,8 @@
         </p:nvSpPr>
         <p:spPr>
           <a:xfrm>
-            <a:off x="594360" y="1234440"/>
-            <a:ext cx="5257800" cy="4389120"/>
+            <a:off x="594360" y="1143000"/>
+            <a:ext cx="10789920" cy="5120640"/>
           </a:xfrm>
           <a:prstGeom prst="rect">
             <a:avLst/>
@@ -4443,7 +3959,7 @@
               <a:defRPr sz="1800"/>
             </a:pPr>
             <a:r>
-              <a:t>Grid: k in {2,4,8,16}, h in {1,2,4,8}</a:t>
+              <a:t>Only three official (k,h) settings for DDIM</a:t>
             </a:r>
           </a:p>
           <a:p>
@@ -4454,7 +3970,7 @@
               <a:defRPr sz="1800"/>
             </a:pPr>
             <a:r>
-              <a:t>Contact-rich pushing makes equal-compute points behave differently</a:t>
+              <a:t>Wall-clock latency not separately benchmarked</a:t>
             </a:r>
           </a:p>
           <a:p>
@@ -4465,35 +3981,22 @@
               <a:defRPr sz="1800"/>
             </a:pPr>
             <a:r>
-              <a:t>The best fixed B=2 score point is (2,1)</a:t>
-            </a:r>
-          </a:p>
-        </p:txBody>
-      </p:sp>
-      <p:pic>
-        <p:nvPicPr>
-          <p:cNvPr id="4" name="Picture 3" descr="kh_score_heatmap.png"/>
-          <p:cNvPicPr>
-            <a:picLocks noChangeAspect="1"/>
-          </p:cNvPicPr>
-          <p:nvPr/>
-        </p:nvPicPr>
-        <p:blipFill>
-          <a:blip r:embed="rId2"/>
-          <a:stretch>
-            <a:fillRect/>
-          </a:stretch>
-        </p:blipFill>
-        <p:spPr>
-          <a:xfrm>
-            <a:off x="6035040" y="1234440"/>
-            <a:ext cx="5577840" cy="4028440"/>
-          </a:xfrm>
-          <a:prstGeom prst="rect">
-            <a:avLst/>
-          </a:prstGeom>
-        </p:spPr>
-      </p:pic>
+              <a:t>Original environment differs from compatibility container</a:t>
+            </a:r>
+          </a:p>
+          <a:p>
+            <a:pPr>
+              <a:spcAft>
+                <a:spcPts val="800"/>
+              </a:spcAft>
+              <a:defRPr sz="1800"/>
+            </a:pPr>
+            <a:r>
+              <a:t>Best high-denoising DDPM baseline remains strong</a:t>
+            </a:r>
+          </a:p>
+        </p:txBody>
+      </p:sp>
     </p:spTree>
   </p:cSld>
   <p:clrMapOvr>
@@ -4529,7 +4032,7 @@
         <p:spPr>
           <a:xfrm>
             <a:off x="411480" y="228600"/>
-            <a:ext cx="11338560" cy="640080"/>
+            <a:ext cx="11155680" cy="594360"/>
           </a:xfrm>
           <a:prstGeom prst="rect">
             <a:avLst/>
@@ -4550,7 +4053,7 @@
               </a:defRPr>
             </a:pPr>
             <a:r>
-              <a:t>Joint Scheduler</a:t>
+              <a:t>Final Claim</a:t>
             </a:r>
           </a:p>
         </p:txBody>
@@ -4563,8 +4066,8 @@
         </p:nvSpPr>
         <p:spPr>
           <a:xfrm>
-            <a:off x="594360" y="1234440"/>
-            <a:ext cx="10789920" cy="4389120"/>
+            <a:off x="594360" y="1143000"/>
+            <a:ext cx="10789920" cy="5120640"/>
           </a:xfrm>
           <a:prstGeom prst="rect">
             <a:avLst/>
@@ -4584,7 +4087,7 @@
               <a:defRPr sz="1800"/>
             </a:pPr>
             <a:r>
-              <a:t>Training-free rule on the B=2 frontier</a:t>
+              <a:t>DDIM sampler replacement is a real implemented improvement</a:t>
             </a:r>
           </a:p>
           <a:p>
@@ -4595,7 +4098,7 @@
               <a:defRPr sz="1800"/>
             </a:pPr>
             <a:r>
-              <a:t>Score variant uses (4,2) in easier phases and (2,1) near contact</a:t>
+              <a:t>It directly improves official low/mid-denoising rollout performance</a:t>
             </a:r>
           </a:p>
           <a:p>
@@ -4606,174 +4109,11 @@
               <a:defRPr sz="1800"/>
             </a:pPr>
             <a:r>
-              <a:t>Safe variant switches to (2,1) earlier</a:t>
-            </a:r>
-          </a:p>
-          <a:p>
-            <a:pPr>
-              <a:spcAft>
-                <a:spcPts val="800"/>
-              </a:spcAft>
-              <a:defRPr sz="1800"/>
-            </a:pPr>
-            <a:r>
-              <a:t>Goal: keep compute fixed while moving reactivity to high-risk phases</a:t>
-            </a:r>
-          </a:p>
-        </p:txBody>
-      </p:sp>
-    </p:spTree>
-  </p:cSld>
-  <p:clrMapOvr>
-    <a:masterClrMapping/>
-  </p:clrMapOvr>
-</p:sld>
-</file>
-
-<file path=ppt/slides/slide9.xml><?xml version="1.0" encoding="utf-8"?>
-<p:sld xmlns:a="http://schemas.openxmlformats.org/drawingml/2006/main" xmlns:p="http://schemas.openxmlformats.org/presentationml/2006/main" xmlns:r="http://schemas.openxmlformats.org/officeDocument/2006/relationships">
-  <p:cSld>
-    <p:bg>
-      <p:bgPr>
-        <a:solidFill>
-          <a:srgbClr val="FAFAF9"/>
-        </a:solidFill>
-        <a:effectLst/>
-      </p:bgPr>
-    </p:bg>
-    <p:spTree>
-      <p:nvGrpSpPr>
-        <p:cNvPr id="1" name=""/>
-        <p:cNvGrpSpPr/>
-        <p:nvPr/>
-      </p:nvGrpSpPr>
-      <p:grpSpPr/>
-      <p:sp>
-        <p:nvSpPr>
-          <p:cNvPr id="2" name="TextBox 1"/>
-          <p:cNvSpPr txBox="1"/>
-          <p:nvPr/>
-        </p:nvSpPr>
-        <p:spPr>
-          <a:xfrm>
-            <a:off x="411480" y="228600"/>
-            <a:ext cx="11338560" cy="640080"/>
-          </a:xfrm>
-          <a:prstGeom prst="rect">
-            <a:avLst/>
-          </a:prstGeom>
-          <a:noFill/>
-        </p:spPr>
-        <p:txBody>
-          <a:bodyPr wrap="none">
-            <a:spAutoFit/>
-          </a:bodyPr>
-          <a:lstStyle/>
-          <a:p>
-            <a:pPr>
-              <a:defRPr sz="3000" b="1">
-                <a:solidFill>
-                  <a:srgbClr val="1F2937"/>
-                </a:solidFill>
-              </a:defRPr>
-            </a:pPr>
-            <a:r>
-              <a:t>Main Results</a:t>
-            </a:r>
-          </a:p>
-        </p:txBody>
-      </p:sp>
-      <p:sp>
-        <p:nvSpPr>
-          <p:cNvPr id="3" name="TextBox 2"/>
-          <p:cNvSpPr txBox="1"/>
-          <p:nvPr/>
-        </p:nvSpPr>
-        <p:spPr>
-          <a:xfrm>
-            <a:off x="594360" y="1234440"/>
-            <a:ext cx="5257800" cy="4389120"/>
-          </a:xfrm>
-          <a:prstGeom prst="rect">
-            <a:avLst/>
-          </a:prstGeom>
-          <a:noFill/>
-        </p:spPr>
-        <p:txBody>
-          <a:bodyPr wrap="none">
-            <a:spAutoFit/>
-          </a:bodyPr>
-          <a:lstStyle/>
-          <a:p>
-            <a:pPr>
-              <a:spcAft>
-                <a:spcPts val="800"/>
-              </a:spcAft>
-              <a:defRPr sz="1800"/>
-            </a:pPr>
-            <a:r>
-              <a:t>Score scheduler: score 0.893, calls 89.2</a:t>
-            </a:r>
-          </a:p>
-          <a:p>
-            <a:pPr>
-              <a:spcAft>
-                <a:spcPts val="800"/>
-              </a:spcAft>
-              <a:defRPr sz="1800"/>
-            </a:pPr>
-            <a:r>
-              <a:t>Safe scheduler: success 0.950, calls 105.3</a:t>
-            </a:r>
-          </a:p>
-          <a:p>
-            <a:pPr>
-              <a:spcAft>
-                <a:spcPts val="800"/>
-              </a:spcAft>
-              <a:defRPr sz="1800"/>
-            </a:pPr>
-            <a:r>
-              <a:t>Best fixed B=2: score 0.871, success 0.900</a:t>
-            </a:r>
-          </a:p>
-          <a:p>
-            <a:pPr>
-              <a:spcAft>
-                <a:spcPts val="800"/>
-              </a:spcAft>
-              <a:defRPr sz="1800"/>
-            </a:pPr>
-            <a:r>
-              <a:t>Result is a Pareto tradeoff, not a single universal winner</a:t>
-            </a:r>
-          </a:p>
-        </p:txBody>
-      </p:sp>
-      <p:pic>
-        <p:nvPicPr>
-          <p:cNvPr id="4" name="Picture 3" descr="main_comparison_bars.png"/>
-          <p:cNvPicPr>
-            <a:picLocks noChangeAspect="1"/>
-          </p:cNvPicPr>
-          <p:nvPr/>
-        </p:nvPicPr>
-        <p:blipFill>
-          <a:blip r:embed="rId2"/>
-          <a:stretch>
-            <a:fillRect/>
-          </a:stretch>
-        </p:blipFill>
-        <p:spPr>
-          <a:xfrm>
-            <a:off x="6035040" y="1234440"/>
-            <a:ext cx="5577840" cy="2252589"/>
-          </a:xfrm>
-          <a:prstGeom prst="rect">
-            <a:avLst/>
-          </a:prstGeom>
-        </p:spPr>
-      </p:pic>
+              <a:t>The project now satisfies reproduction + improvement requirements</a:t>
+            </a:r>
+          </a:p>
+        </p:txBody>
+      </p:sp>
     </p:spTree>
   </p:cSld>
   <p:clrMapOvr>

</xml_diff>